<commit_message>
Update Binary Encoding presentation file
</commit_message>
<xml_diff>
--- a/My Note and Practice/Text to Numerical Data Conversion/Categorical(Text to Numeric) data conversion-CTtN/Nominal Data/CTNtN2. Binary Encoding/Binary Encoding.pptx
+++ b/My Note and Practice/Text to Numerical Data Conversion/Categorical(Text to Numeric) data conversion-CTtN/Nominal Data/CTNtN2. Binary Encoding/Binary Encoding.pptx
@@ -5,11 +5,12 @@
     <p:sldMasterId id="2147483648" r:id="rId1"/>
   </p:sldMasterIdLst>
   <p:sldIdLst>
-    <p:sldId id="309" r:id="rId2"/>
-    <p:sldId id="310" r:id="rId3"/>
-    <p:sldId id="321" r:id="rId4"/>
-    <p:sldId id="311" r:id="rId5"/>
-    <p:sldId id="320" r:id="rId6"/>
+    <p:sldId id="322" r:id="rId2"/>
+    <p:sldId id="309" r:id="rId3"/>
+    <p:sldId id="310" r:id="rId4"/>
+    <p:sldId id="321" r:id="rId5"/>
+    <p:sldId id="311" r:id="rId6"/>
+    <p:sldId id="320" r:id="rId7"/>
   </p:sldIdLst>
   <p:sldSz cx="12192000" cy="6858000"/>
   <p:notesSz cx="6858000" cy="9144000"/>
@@ -263,7 +264,7 @@
           <a:p>
             <a:fld id="{BC408777-D8E4-48B9-88F2-93B50ADA839C}" type="datetimeFigureOut">
               <a:rPr lang="en-US" smtClean="0"/>
-              <a:t>11/17/2025</a:t>
+              <a:t>11/19/2025</a:t>
             </a:fld>
             <a:endParaRPr lang="en-US"/>
           </a:p>
@@ -461,7 +462,7 @@
           <a:p>
             <a:fld id="{BC408777-D8E4-48B9-88F2-93B50ADA839C}" type="datetimeFigureOut">
               <a:rPr lang="en-US" smtClean="0"/>
-              <a:t>11/17/2025</a:t>
+              <a:t>11/19/2025</a:t>
             </a:fld>
             <a:endParaRPr lang="en-US"/>
           </a:p>
@@ -669,7 +670,7 @@
           <a:p>
             <a:fld id="{BC408777-D8E4-48B9-88F2-93B50ADA839C}" type="datetimeFigureOut">
               <a:rPr lang="en-US" smtClean="0"/>
-              <a:t>11/17/2025</a:t>
+              <a:t>11/19/2025</a:t>
             </a:fld>
             <a:endParaRPr lang="en-US"/>
           </a:p>
@@ -867,7 +868,7 @@
           <a:p>
             <a:fld id="{BC408777-D8E4-48B9-88F2-93B50ADA839C}" type="datetimeFigureOut">
               <a:rPr lang="en-US" smtClean="0"/>
-              <a:t>11/17/2025</a:t>
+              <a:t>11/19/2025</a:t>
             </a:fld>
             <a:endParaRPr lang="en-US"/>
           </a:p>
@@ -1142,7 +1143,7 @@
           <a:p>
             <a:fld id="{BC408777-D8E4-48B9-88F2-93B50ADA839C}" type="datetimeFigureOut">
               <a:rPr lang="en-US" smtClean="0"/>
-              <a:t>11/17/2025</a:t>
+              <a:t>11/19/2025</a:t>
             </a:fld>
             <a:endParaRPr lang="en-US"/>
           </a:p>
@@ -1407,7 +1408,7 @@
           <a:p>
             <a:fld id="{BC408777-D8E4-48B9-88F2-93B50ADA839C}" type="datetimeFigureOut">
               <a:rPr lang="en-US" smtClean="0"/>
-              <a:t>11/17/2025</a:t>
+              <a:t>11/19/2025</a:t>
             </a:fld>
             <a:endParaRPr lang="en-US"/>
           </a:p>
@@ -1819,7 +1820,7 @@
           <a:p>
             <a:fld id="{BC408777-D8E4-48B9-88F2-93B50ADA839C}" type="datetimeFigureOut">
               <a:rPr lang="en-US" smtClean="0"/>
-              <a:t>11/17/2025</a:t>
+              <a:t>11/19/2025</a:t>
             </a:fld>
             <a:endParaRPr lang="en-US"/>
           </a:p>
@@ -1960,7 +1961,7 @@
           <a:p>
             <a:fld id="{BC408777-D8E4-48B9-88F2-93B50ADA839C}" type="datetimeFigureOut">
               <a:rPr lang="en-US" smtClean="0"/>
-              <a:t>11/17/2025</a:t>
+              <a:t>11/19/2025</a:t>
             </a:fld>
             <a:endParaRPr lang="en-US"/>
           </a:p>
@@ -2073,7 +2074,7 @@
           <a:p>
             <a:fld id="{BC408777-D8E4-48B9-88F2-93B50ADA839C}" type="datetimeFigureOut">
               <a:rPr lang="en-US" smtClean="0"/>
-              <a:t>11/17/2025</a:t>
+              <a:t>11/19/2025</a:t>
             </a:fld>
             <a:endParaRPr lang="en-US"/>
           </a:p>
@@ -2384,7 +2385,7 @@
           <a:p>
             <a:fld id="{BC408777-D8E4-48B9-88F2-93B50ADA839C}" type="datetimeFigureOut">
               <a:rPr lang="en-US" smtClean="0"/>
-              <a:t>11/17/2025</a:t>
+              <a:t>11/19/2025</a:t>
             </a:fld>
             <a:endParaRPr lang="en-US"/>
           </a:p>
@@ -2672,7 +2673,7 @@
           <a:p>
             <a:fld id="{BC408777-D8E4-48B9-88F2-93B50ADA839C}" type="datetimeFigureOut">
               <a:rPr lang="en-US" smtClean="0"/>
-              <a:t>11/17/2025</a:t>
+              <a:t>11/19/2025</a:t>
             </a:fld>
             <a:endParaRPr lang="en-US"/>
           </a:p>
@@ -2913,7 +2914,7 @@
           <a:p>
             <a:fld id="{BC408777-D8E4-48B9-88F2-93B50ADA839C}" type="datetimeFigureOut">
               <a:rPr lang="en-US" smtClean="0"/>
-              <a:t>11/17/2025</a:t>
+              <a:t>11/19/2025</a:t>
             </a:fld>
             <a:endParaRPr lang="en-US"/>
           </a:p>
@@ -3314,6 +3315,112 @@
 </file>
 
 <file path=ppt/slides/slide1.xml><?xml version="1.0" encoding="utf-8"?>
+<p:sld xmlns:a="http://schemas.openxmlformats.org/drawingml/2006/main" xmlns:r="http://schemas.openxmlformats.org/officeDocument/2006/relationships" xmlns:p="http://schemas.openxmlformats.org/presentationml/2006/main">
+  <p:cSld>
+    <p:spTree>
+      <p:nvGrpSpPr>
+        <p:cNvPr id="1" name=""/>
+        <p:cNvGrpSpPr/>
+        <p:nvPr/>
+      </p:nvGrpSpPr>
+      <p:grpSpPr>
+        <a:xfrm>
+          <a:off x="0" y="0"/>
+          <a:ext cx="0" cy="0"/>
+          <a:chOff x="0" y="0"/>
+          <a:chExt cx="0" cy="0"/>
+        </a:xfrm>
+      </p:grpSpPr>
+      <p:sp>
+        <p:nvSpPr>
+          <p:cNvPr id="2" name="Title 1">
+            <a:extLst>
+              <a:ext uri="{FF2B5EF4-FFF2-40B4-BE49-F238E27FC236}">
+                <a16:creationId xmlns:a16="http://schemas.microsoft.com/office/drawing/2014/main" id="{F5B3AA89-B853-FD45-602D-8D0552F6CFA2}"/>
+              </a:ext>
+            </a:extLst>
+          </p:cNvPr>
+          <p:cNvSpPr>
+            <a:spLocks noGrp="1"/>
+          </p:cNvSpPr>
+          <p:nvPr>
+            <p:ph type="ctrTitle"/>
+          </p:nvPr>
+        </p:nvSpPr>
+        <p:spPr/>
+        <p:txBody>
+          <a:bodyPr/>
+          <a:lstStyle/>
+          <a:p>
+            <a:r>
+              <a:rPr lang="en-US" dirty="0">
+                <a:latin typeface="Bebas Neue" panose="020B0606020202050201" pitchFamily="34" charset="0"/>
+              </a:rPr>
+              <a:t>Binary Encoding in Machine Learning</a:t>
+            </a:r>
+          </a:p>
+        </p:txBody>
+      </p:sp>
+      <p:sp>
+        <p:nvSpPr>
+          <p:cNvPr id="3" name="Subtitle 2">
+            <a:extLst>
+              <a:ext uri="{FF2B5EF4-FFF2-40B4-BE49-F238E27FC236}">
+                <a16:creationId xmlns:a16="http://schemas.microsoft.com/office/drawing/2014/main" id="{C5758605-EE53-5BCE-68EE-DF7AECF12555}"/>
+              </a:ext>
+            </a:extLst>
+          </p:cNvPr>
+          <p:cNvSpPr>
+            <a:spLocks noGrp="1"/>
+          </p:cNvSpPr>
+          <p:nvPr>
+            <p:ph type="subTitle" idx="1"/>
+          </p:nvPr>
+        </p:nvSpPr>
+        <p:spPr/>
+        <p:txBody>
+          <a:bodyPr>
+            <a:normAutofit/>
+          </a:bodyPr>
+          <a:lstStyle/>
+          <a:p>
+            <a:r>
+              <a:rPr lang="en-US" sz="3200" i="1" dirty="0">
+                <a:latin typeface="Open Sans" pitchFamily="2" charset="0"/>
+                <a:ea typeface="Open Sans" pitchFamily="2" charset="0"/>
+                <a:cs typeface="Open Sans" pitchFamily="2" charset="0"/>
+              </a:rPr>
+              <a:t>A Hybrid Technique Combining Hashing and One-Hot Encoding for Efficient Categorical Encoding</a:t>
+            </a:r>
+            <a:endParaRPr lang="en-US" sz="3200" dirty="0">
+              <a:latin typeface="Open Sans" pitchFamily="2" charset="0"/>
+              <a:ea typeface="Open Sans" pitchFamily="2" charset="0"/>
+              <a:cs typeface="Open Sans" pitchFamily="2" charset="0"/>
+            </a:endParaRPr>
+          </a:p>
+          <a:p>
+            <a:endParaRPr lang="en-US" sz="3200" dirty="0">
+              <a:latin typeface="Open Sans" pitchFamily="2" charset="0"/>
+              <a:ea typeface="Open Sans" pitchFamily="2" charset="0"/>
+              <a:cs typeface="Open Sans" pitchFamily="2" charset="0"/>
+            </a:endParaRPr>
+          </a:p>
+        </p:txBody>
+      </p:sp>
+    </p:spTree>
+    <p:extLst>
+      <p:ext uri="{BB962C8B-B14F-4D97-AF65-F5344CB8AC3E}">
+        <p14:creationId xmlns:p14="http://schemas.microsoft.com/office/powerpoint/2010/main" val="119624363"/>
+      </p:ext>
+    </p:extLst>
+  </p:cSld>
+  <p:clrMapOvr>
+    <a:masterClrMapping/>
+  </p:clrMapOvr>
+</p:sld>
+</file>
+
+<file path=ppt/slides/slide2.xml><?xml version="1.0" encoding="utf-8"?>
 <p:sld xmlns:a="http://schemas.openxmlformats.org/drawingml/2006/main" xmlns:r="http://schemas.openxmlformats.org/officeDocument/2006/relationships" xmlns:p="http://schemas.openxmlformats.org/presentationml/2006/main">
   <p:cSld>
     <p:spTree>
@@ -4503,7 +4610,7 @@
 </p:sld>
 </file>
 
-<file path=ppt/slides/slide2.xml><?xml version="1.0" encoding="utf-8"?>
+<file path=ppt/slides/slide3.xml><?xml version="1.0" encoding="utf-8"?>
 <p:sld xmlns:a="http://schemas.openxmlformats.org/drawingml/2006/main" xmlns:r="http://schemas.openxmlformats.org/officeDocument/2006/relationships" xmlns:p="http://schemas.openxmlformats.org/presentationml/2006/main">
   <p:cSld>
     <p:spTree>
@@ -4782,7 +4889,7 @@
 </p:sld>
 </file>
 
-<file path=ppt/slides/slide3.xml><?xml version="1.0" encoding="utf-8"?>
+<file path=ppt/slides/slide4.xml><?xml version="1.0" encoding="utf-8"?>
 <p:sld xmlns:a="http://schemas.openxmlformats.org/drawingml/2006/main" xmlns:r="http://schemas.openxmlformats.org/officeDocument/2006/relationships" xmlns:p="http://schemas.openxmlformats.org/presentationml/2006/main">
   <p:cSld>
     <p:spTree>
@@ -5055,7 +5162,7 @@
 </p:sld>
 </file>
 
-<file path=ppt/slides/slide4.xml><?xml version="1.0" encoding="utf-8"?>
+<file path=ppt/slides/slide5.xml><?xml version="1.0" encoding="utf-8"?>
 <p:sld xmlns:a="http://schemas.openxmlformats.org/drawingml/2006/main" xmlns:r="http://schemas.openxmlformats.org/officeDocument/2006/relationships" xmlns:p="http://schemas.openxmlformats.org/presentationml/2006/main">
   <p:cSld>
     <p:spTree>
@@ -5269,7 +5376,7 @@
 </p:sld>
 </file>
 
-<file path=ppt/slides/slide5.xml><?xml version="1.0" encoding="utf-8"?>
+<file path=ppt/slides/slide6.xml><?xml version="1.0" encoding="utf-8"?>
 <p:sld xmlns:a="http://schemas.openxmlformats.org/drawingml/2006/main" xmlns:r="http://schemas.openxmlformats.org/officeDocument/2006/relationships" xmlns:p="http://schemas.openxmlformats.org/presentationml/2006/main">
   <p:cSld>
     <p:spTree>

</xml_diff>